<commit_message>
ci: publica relatorio do Playwright como artefato + docs e Aula B5
- workflow: reporter html (open:never) + list no CI; upload playwright-report e
  test-results (em falha); resumo com instrucoes de download do artefato
- readme/TESTES: como baixar e abrir o relatorio do CI
- AulaB5.pptx: destaca o passo de criacao do plano de testes (BDD/PLAN-TEST.md),
  automacao e2e no GitHub Actions e o comparativo Lighthouse F12 x PageSpeed

Co-Authored-By: Claude Opus 4.8 (1M context) <noreply@anthropic.com>
</commit_message>
<xml_diff>
--- a/docs/AulaB5_Seguranca_de_Software.pptx
+++ b/docs/AulaB5_Seguranca_de_Software.pptx
@@ -5058,7 +5058,41 @@
                 <a:ea typeface="Calibri" pitchFamily="34" charset="-122"/>
                 <a:cs typeface="Calibri" pitchFamily="34" charset="-120"/>
               </a:rPr>
-              <a:t>npm audit/Dependabot, OWASP ZAP, e o próprio Catch-Requests para inspecionar o tráfego.</a:t>
+              <a:t>npm audit/Dependabot, OWASP ZAP, Lighthouse (F12/PageSpeed) e o Catch-Requests.</a:t>
+            </a:r>
+            <a:endParaRPr lang="en-US" sz="1350" dirty="0"/>
+          </a:p>
+          <a:p>
+            <a:pPr indent="0" marL="0">
+              <a:buNone/>
+            </a:pPr>
+            <a:r>
+              <a:rPr lang="en-US" sz="1350" b="1" dirty="0">
+                <a:solidFill>
+                  <a:srgbClr val="2E7D32"/>
+                </a:solidFill>
+                <a:latin typeface="Calibri" pitchFamily="34" charset="0"/>
+                <a:ea typeface="Calibri" pitchFamily="34" charset="-122"/>
+                <a:cs typeface="Calibri" pitchFamily="34" charset="-120"/>
+              </a:rPr>
+              <a:t>Plano de testes (BDD): </a:t>
+            </a:r>
+            <a:pPr indent="0" marL="0">
+              <a:spcAft>
+                <a:spcPts val="700"/>
+              </a:spcAft>
+              <a:buNone/>
+            </a:pPr>
+            <a:r>
+              <a:rPr lang="en-US" sz="1350" dirty="0">
+                <a:solidFill>
+                  <a:srgbClr val="55695C"/>
+                </a:solidFill>
+                <a:latin typeface="Calibri" pitchFamily="34" charset="0"/>
+                <a:ea typeface="Calibri" pitchFamily="34" charset="-122"/>
+                <a:cs typeface="Calibri" pitchFamily="34" charset="-120"/>
+              </a:rPr>
+              <a:t>antes de automatizar, escreva os cenarios em Gherkin (Dado/Quando/Entao). No projeto virou o PLAN-TEST.md, base dos 18 testes e2e (Playwright) no CI.</a:t>
             </a:r>
             <a:endParaRPr lang="en-US" sz="1350" dirty="0"/>
           </a:p>
@@ -5331,7 +5365,7 @@
                 <a:ea typeface="Calibri" pitchFamily="34" charset="-122"/>
                 <a:cs typeface="Calibri" pitchFamily="34" charset="-120"/>
               </a:rPr>
-              <a:t>O QA pensa como um atacante para proteger o usuário — e faz isso cedo.</a:t>
+              <a:t>O QA pensa como um atacante para proteger o usuario — e faz isso cedo e de forma automatizada (CI).</a:t>
             </a:r>
             <a:endParaRPr lang="en-US" sz="1350" dirty="0"/>
           </a:p>
@@ -6731,7 +6765,7 @@
                 <a:ea typeface="Calibri" pitchFamily="34" charset="-122"/>
                 <a:cs typeface="Calibri" pitchFamily="34" charset="-120"/>
               </a:rPr>
-              <a:t>Segurança é parte do QA: teste o caminho malicioso, cedo (shift-left).</a:t>
+              <a:t>Segurança é parte do QA: escreva o plano de testes (BDD) e teste o caminho malicioso, cedo (shift-left).</a:t>
             </a:r>
             <a:endParaRPr lang="en-US" sz="1500" dirty="0"/>
           </a:p>

</xml_diff>